<commit_message>
Remove reference answer labels
</commit_message>
<xml_diff>
--- a/presentation_student_dropout.pptx
+++ b/presentation_student_dropout.pptx
@@ -1861,7 +1861,7 @@
                   <a:srgbClr val="5B6770"/>
                 </a:solidFill>
               </a:rPr>
-              <a:t>DSAA2011 Student Dropout Reference | 1/6</a:t>
+              <a:t>DSAA2011 Student Dropout | 1/6</a:t>
             </a:r>
             <a:endParaRPr lang="en-US" sz="750" dirty="0"/>
           </a:p>
@@ -2899,7 +2899,7 @@
                   <a:srgbClr val="5B6770"/>
                 </a:solidFill>
               </a:rPr>
-              <a:t>DSAA2011 Student Dropout Reference | 2/6</a:t>
+              <a:t>DSAA2011 Student Dropout | 2/6</a:t>
             </a:r>
             <a:endParaRPr lang="en-US" sz="750" dirty="0"/>
           </a:p>
@@ -3205,7 +3205,7 @@
                   <a:srgbClr val="5B6770"/>
                 </a:solidFill>
               </a:rPr>
-              <a:t>DSAA2011 Student Dropout Reference | 3/6</a:t>
+              <a:t>DSAA2011 Student Dropout | 3/6</a:t>
             </a:r>
             <a:endParaRPr lang="en-US" sz="750" dirty="0"/>
           </a:p>
@@ -4731,7 +4731,7 @@
                   <a:srgbClr val="5B6770"/>
                 </a:solidFill>
               </a:rPr>
-              <a:t>DSAA2011 Student Dropout Reference | 4/6</a:t>
+              <a:t>DSAA2011 Student Dropout | 4/6</a:t>
             </a:r>
             <a:endParaRPr lang="en-US" sz="750" dirty="0"/>
           </a:p>
@@ -5037,7 +5037,7 @@
                   <a:srgbClr val="5B6770"/>
                 </a:solidFill>
               </a:rPr>
-              <a:t>DSAA2011 Student Dropout Reference | 5/6</a:t>
+              <a:t>DSAA2011 Student Dropout | 5/6</a:t>
             </a:r>
             <a:endParaRPr lang="en-US" sz="750" dirty="0"/>
           </a:p>
@@ -5565,39 +5565,6 @@
         </p:nvSpPr>
         <p:spPr>
           <a:xfrm>
-            <a:off x="804672" y="5797296"/>
-            <a:ext cx="10607040" cy="310896"/>
-          </a:xfrm>
-          <a:prstGeom prst="rect">
-            <a:avLst/>
-          </a:prstGeom>
-          <a:noFill/>
-          <a:ln/>
-        </p:spPr>
-        <p:txBody>
-          <a:bodyPr wrap="square" lIns="254" tIns="254" rIns="254" bIns="254" rtlCol="0" anchor="ctr"/>
-          <a:lstStyle/>
-          <a:p>
-            <a:r>
-              <a:rPr lang="en-US" sz="1100" dirty="0">
-                <a:solidFill>
-                  <a:srgbClr val="1F2933"/>
-                </a:solidFill>
-              </a:rPr>
-              <a:t>本答案仅供参考评分标准，学生核心ML实现需独立完成。</a:t>
-            </a:r>
-            <a:endParaRPr lang="en-US" sz="1100" dirty="0"/>
-          </a:p>
-        </p:txBody>
-      </p:sp>
-      <p:sp>
-        <p:nvSpPr>
-          <p:cNvPr id="18" name="Text 14"/>
-          <p:cNvSpPr/>
-          <p:nvPr/>
-        </p:nvSpPr>
-        <p:spPr>
-          <a:xfrm>
             <a:off x="822960" y="6153912"/>
             <a:ext cx="9966960" cy="164592"/>
           </a:xfrm>
@@ -5628,7 +5595,7 @@
       </p:sp>
       <p:sp>
         <p:nvSpPr>
-          <p:cNvPr id="19" name="Text 15"/>
+          <p:cNvPr id="18" name="Text 14"/>
           <p:cNvSpPr/>
           <p:nvPr/>
         </p:nvSpPr>
@@ -5656,7 +5623,7 @@
                   <a:srgbClr val="5B6770"/>
                 </a:solidFill>
               </a:rPr>
-              <a:t>DSAA2011 Student Dropout Reference | 6/6</a:t>
+              <a:t>DSAA2011 Student Dropout | 6/6</a:t>
             </a:r>
             <a:endParaRPr lang="en-US" sz="750" dirty="0"/>
           </a:p>

</xml_diff>